<commit_message>
Update deck: evaluation round 2
</commit_message>
<xml_diff>
--- a/Tavorix-Token-Check-pitch-deck (6).pptx
+++ b/Tavorix-Token-Check-pitch-deck (6).pptx
@@ -1977,7 +1977,7 @@
                   <a:schemeClr val="bg1"/>
                 </a:solidFill>
               </a:rPr>
-              <a:t>Public demo (live), documentation, labeled dataset from 23 to 35 verified entries.</a:t>
+              <a:t>Public demo (live), documentation, a frozen held-out test list, and more active scam examples.</a:t>
             </a:r>
             <a:endParaRPr lang="en-US" sz="1700" dirty="0"/>
           </a:p>
@@ -2095,7 +2095,7 @@
                   <a:schemeClr val="bg1"/>
                 </a:solidFill>
               </a:rPr>
-              <a:t>Improve detection of old rugpulls (4 were missed), then a small-sample accuracy report including failures.</a:t>
+              <a:t>Improve old-rugpull detection (7 of 10 missed), then re-measure on new rows and publish all results.</a:t>
             </a:r>
             <a:endParaRPr lang="en-US" sz="1700" dirty="0"/>
           </a:p>
@@ -2607,7 +2607,7 @@
                   <a:schemeClr val="bg1"/>
                 </a:solidFill>
               </a:rPr>
-              <a:t>Dataset to 35 verified tokens, then a public accuracy report including failures.</a:t>
+              <a:t>More active scam examples and a frozen test list, then a new evaluation including failures.</a:t>
             </a:r>
             <a:endParaRPr lang="en-US" sz="1800" dirty="0"/>
           </a:p>
@@ -6086,7 +6086,7 @@
                   <a:schemeClr val="bg1"/>
                 </a:solidFill>
               </a:rPr>
-              <a:t>Labeled dataset (initial sample of 23 tokens)</a:t>
+              <a:t>Labeled dataset (34 scored tokens)</a:t>
             </a:r>
             <a:endParaRPr lang="en-US" sz="1800" dirty="0"/>
           </a:p>
@@ -6354,7 +6354,7 @@
                   <a:schemeClr val="bg2"/>
                 </a:solidFill>
               </a:rPr>
-              <a:t>Initial evaluation published with all failures (it missed 4 old rugpull examples). No accuracy claims yet. Scores are estimates and not financial advice.</a:t>
+              <a:t>Latest evaluation (34 tokens) published with all failures: it caught 3 of 10 old rugpulls and falsely flagged 6 of 24 healthy tokens. No accuracy claims. Scores are estimates, not financial advice.</a:t>
             </a:r>
             <a:endParaRPr lang="en-US" sz="1500" dirty="0"/>
           </a:p>

</xml_diff>